<commit_message>
Validar el modelo local y simplificar las guías de uso
</commit_message>
<xml_diff>
--- a/entregables/presentacion.pptx
+++ b/entregables/presentacion.pptx
@@ -2,20 +2,20 @@
 <file path=ppt/presentation.xml><?xml version="1.0" encoding="utf-8"?>
 <p:presentation xmlns:p="http://schemas.openxmlformats.org/presentationml/2006/main">
   <p:sldMasterIdLst>
-    <p:sldMasterId xmlns:r="http://schemas.openxmlformats.org/officeDocument/2006/relationships" id="2147483648" r:id="Rd305638a5a364e91"/>
+    <p:sldMasterId xmlns:r="http://schemas.openxmlformats.org/officeDocument/2006/relationships" id="2147483648" r:id="R4fa825a69df141da"/>
   </p:sldMasterIdLst>
   <p:notesMasterIdLst>
-    <p:notesMasterId xmlns:r="http://schemas.openxmlformats.org/officeDocument/2006/relationships" r:id="R9e1726d4d318460a"/>
+    <p:notesMasterId xmlns:r="http://schemas.openxmlformats.org/officeDocument/2006/relationships" r:id="R209d7063d614431f"/>
   </p:notesMasterIdLst>
   <p:sldIdLst>
-    <p:sldId xmlns:r="http://schemas.openxmlformats.org/officeDocument/2006/relationships" id="256" r:id="Rc96ac8747b25490b"/>
-    <p:sldId xmlns:r="http://schemas.openxmlformats.org/officeDocument/2006/relationships" id="257" r:id="Rfe52a5a1d3a34ef9"/>
-    <p:sldId xmlns:r="http://schemas.openxmlformats.org/officeDocument/2006/relationships" id="258" r:id="Rec1471d756104522"/>
-    <p:sldId xmlns:r="http://schemas.openxmlformats.org/officeDocument/2006/relationships" id="259" r:id="R5881fd7eefef4919"/>
-    <p:sldId xmlns:r="http://schemas.openxmlformats.org/officeDocument/2006/relationships" id="260" r:id="R564cae1ba1e2424f"/>
-    <p:sldId xmlns:r="http://schemas.openxmlformats.org/officeDocument/2006/relationships" id="261" r:id="Rbec934919d404be5"/>
-    <p:sldId xmlns:r="http://schemas.openxmlformats.org/officeDocument/2006/relationships" id="262" r:id="Ra938750065004377"/>
-    <p:sldId xmlns:r="http://schemas.openxmlformats.org/officeDocument/2006/relationships" id="263" r:id="R5605acf75b364cb8"/>
+    <p:sldId xmlns:r="http://schemas.openxmlformats.org/officeDocument/2006/relationships" id="256" r:id="Rec005557af1048dd"/>
+    <p:sldId xmlns:r="http://schemas.openxmlformats.org/officeDocument/2006/relationships" id="257" r:id="R2e68073a55f14c2a"/>
+    <p:sldId xmlns:r="http://schemas.openxmlformats.org/officeDocument/2006/relationships" id="258" r:id="Re44b393ca9f34600"/>
+    <p:sldId xmlns:r="http://schemas.openxmlformats.org/officeDocument/2006/relationships" id="259" r:id="Re5a5091d1f27472b"/>
+    <p:sldId xmlns:r="http://schemas.openxmlformats.org/officeDocument/2006/relationships" id="260" r:id="Rd151e5cfc955490d"/>
+    <p:sldId xmlns:r="http://schemas.openxmlformats.org/officeDocument/2006/relationships" id="261" r:id="R00e427dd15fa463f"/>
+    <p:sldId xmlns:r="http://schemas.openxmlformats.org/officeDocument/2006/relationships" id="262" r:id="R18571fcb70b1446d"/>
+    <p:sldId xmlns:r="http://schemas.openxmlformats.org/officeDocument/2006/relationships" id="263" r:id="R78ddd37545324591"/>
   </p:sldIdLst>
   <p:sldSz cx="12192000" cy="6858000"/>
   <p:notesSz cx="6858000" cy="9144000"/>
@@ -869,7 +869,7 @@
           <a:lstStyle xmlns:a="http://schemas.openxmlformats.org/drawingml/2006/main"/>
           <a:p xmlns:a="http://schemas.openxmlformats.org/drawingml/2006/main">
             <a:r>
-              <a:t>Duración: 70 segundos. Fuente: evidencias/evaluacion_documental.json. Diez consultas con documentos esperados, dos fuera de alcance. Conjunto pequeño diseñado a partir del corpus. No se midió fidelidad generativa, porque no se ejecutó Ollama en el entorno de preparación.</a:t>
+              <a:t>Duración: 70 segundos. Fuente: evidencias/evaluacion_llm.json. Diez consultas con documentos esperados y dos fuera de alcance. Se ejecutó Qwen3 4B con EmbeddingGemma en Ollama 0.34.4. El tiempo mediano de las diez respuestas fue de 3,7 segundos con modelos cargados. La revisión señala imprecisiones en C04 y C07. No afirmar fidelidad semántica perfecta.</a:t>
             </a:r>
           </a:p>
         </p:txBody>
@@ -1007,7 +1007,7 @@
   </p:cSld>
   <p:clrMap bg1="lt1" tx1="dk1" bg2="lt2" tx2="dk2" accent1="accent1" accent2="accent2" accent3="accent3" accent4="accent4" accent5="accent5" accent6="accent6" hlink="hlink" folHlink="folHlink"/>
   <p:sldLayoutIdLst>
-    <p:sldLayoutId xmlns:r="http://schemas.openxmlformats.org/officeDocument/2006/relationships" id="2147483649" r:id="R4cdd339cb51d4a4d"/>
+    <p:sldLayoutId xmlns:r="http://schemas.openxmlformats.org/officeDocument/2006/relationships" id="2147483649" r:id="R6f075fcf36044a3d"/>
   </p:sldLayoutIdLst>
   <p:txStyles>
     <p:titleStyle>
@@ -1558,7 +1558,7 @@
           <p:cNvPr id="6" name="">
             <a:extLst xmlns:a="http://schemas.openxmlformats.org/drawingml/2006/main">
               <a:ext uri="{FF2B5EF4-FFF2-40B4-BE49-F238E27FC236}">
-                <a16:creationId xmlns:a16="http://schemas.microsoft.com/office/drawing/2014/main" id="{2528D249-415B-4D98-AECA-6A8C16EBCCAD}"/>
+                <a16:creationId xmlns:a16="http://schemas.microsoft.com/office/drawing/2014/main" id="{EDA3EEBF-E2CA-45EB-AE4A-E84D58B16B0E}"/>
               </a:ext>
             </a:extLst>
           </p:cNvPr>
@@ -1615,7 +1615,7 @@
           <p:cNvPr id="2" name="">
             <a:extLst xmlns:a="http://schemas.openxmlformats.org/drawingml/2006/main">
               <a:ext uri="{FF2B5EF4-FFF2-40B4-BE49-F238E27FC236}">
-                <a16:creationId xmlns:a16="http://schemas.microsoft.com/office/drawing/2014/main" id="{6F812ACC-2E57-4614-A779-ED6AEF680810}"/>
+                <a16:creationId xmlns:a16="http://schemas.microsoft.com/office/drawing/2014/main" id="{6AA24A67-160A-4464-BB18-6BFB9B594364}"/>
               </a:ext>
             </a:extLst>
           </p:cNvPr>
@@ -1672,7 +1672,7 @@
           <p:cNvPr id="3" name="">
             <a:extLst xmlns:a="http://schemas.openxmlformats.org/drawingml/2006/main">
               <a:ext uri="{FF2B5EF4-FFF2-40B4-BE49-F238E27FC236}">
-                <a16:creationId xmlns:a16="http://schemas.microsoft.com/office/drawing/2014/main" id="{3B4F411D-9807-4B45-9465-805872E8D2FE}"/>
+                <a16:creationId xmlns:a16="http://schemas.microsoft.com/office/drawing/2014/main" id="{B77096FD-AAEA-47D3-963E-03BDD4A54F0A}"/>
               </a:ext>
             </a:extLst>
           </p:cNvPr>
@@ -1719,7 +1719,7 @@
                 <a:ea typeface="Arial"/>
                 <a:cs typeface="Arial"/>
               </a:rPr>
-              <a:t>Asistencia de TI con LLM y RAG</a:t>
+              <a:t>Un asistente para dudas de soporte TI</a:t>
             </a:r>
           </a:p>
         </p:txBody>
@@ -1729,7 +1729,7 @@
           <p:cNvPr id="4" name="">
             <a:extLst xmlns:a="http://schemas.openxmlformats.org/drawingml/2006/main">
               <a:ext uri="{FF2B5EF4-FFF2-40B4-BE49-F238E27FC236}">
-                <a16:creationId xmlns:a16="http://schemas.microsoft.com/office/drawing/2014/main" id="{35638E79-E18B-4771-B3AC-C75860EB00BB}"/>
+                <a16:creationId xmlns:a16="http://schemas.microsoft.com/office/drawing/2014/main" id="{B31F76CE-FF7E-46AA-B9EE-C0BA32188E1D}"/>
               </a:ext>
             </a:extLst>
           </p:cNvPr>
@@ -1809,7 +1809,7 @@
           <p:cNvPr id="5" name="">
             <a:extLst xmlns:a="http://schemas.openxmlformats.org/drawingml/2006/main">
               <a:ext uri="{FF2B5EF4-FFF2-40B4-BE49-F238E27FC236}">
-                <a16:creationId xmlns:a16="http://schemas.microsoft.com/office/drawing/2014/main" id="{DE158FCB-9D1C-4296-BE8B-5CE9FEA6A76A}"/>
+                <a16:creationId xmlns:a16="http://schemas.microsoft.com/office/drawing/2014/main" id="{27054057-812B-42E9-850F-8963984590DC}"/>
               </a:ext>
             </a:extLst>
           </p:cNvPr>
@@ -1864,7 +1864,7 @@
     </p:spTree>
     <p:extLst>
       <p:ext uri="{BB962C8B-B14F-4D97-AF65-F5344CB8AC3E}">
-        <p14:creationId xmlns:p14="http://schemas.microsoft.com/office/powerpoint/2010/main" val="1685389122"/>
+        <p14:creationId xmlns:p14="http://schemas.microsoft.com/office/powerpoint/2010/main" val="504020309"/>
       </p:ext>
     </p:extLst>
   </p:cSld>
@@ -1895,7 +1895,7 @@
           <p:cNvPr id="6" name="">
             <a:extLst xmlns:a="http://schemas.openxmlformats.org/drawingml/2006/main">
               <a:ext uri="{FF2B5EF4-FFF2-40B4-BE49-F238E27FC236}">
-                <a16:creationId xmlns:a16="http://schemas.microsoft.com/office/drawing/2014/main" id="{419A342A-BA60-43DC-8E9F-1D3FCB9FD790}"/>
+                <a16:creationId xmlns:a16="http://schemas.microsoft.com/office/drawing/2014/main" id="{392673D1-BDC2-4893-A1D5-BE827BDC9466}"/>
               </a:ext>
             </a:extLst>
           </p:cNvPr>
@@ -1952,7 +1952,7 @@
           <p:cNvPr id="2" name="">
             <a:extLst xmlns:a="http://schemas.openxmlformats.org/drawingml/2006/main">
               <a:ext uri="{FF2B5EF4-FFF2-40B4-BE49-F238E27FC236}">
-                <a16:creationId xmlns:a16="http://schemas.microsoft.com/office/drawing/2014/main" id="{25267D56-0CEC-4BF2-9806-0469FE71D47D}"/>
+                <a16:creationId xmlns:a16="http://schemas.microsoft.com/office/drawing/2014/main" id="{72027BDC-AA26-40E5-9088-E0AB8455A268}"/>
               </a:ext>
             </a:extLst>
           </p:cNvPr>
@@ -2009,7 +2009,7 @@
           <p:cNvPr id="3" name="">
             <a:extLst xmlns:a="http://schemas.openxmlformats.org/drawingml/2006/main">
               <a:ext uri="{FF2B5EF4-FFF2-40B4-BE49-F238E27FC236}">
-                <a16:creationId xmlns:a16="http://schemas.microsoft.com/office/drawing/2014/main" id="{6F4EF884-B9B8-41A6-A1FC-274DAE94150A}"/>
+                <a16:creationId xmlns:a16="http://schemas.microsoft.com/office/drawing/2014/main" id="{23523E3F-00ED-468E-BDF7-F5CDF85E133C}"/>
               </a:ext>
             </a:extLst>
           </p:cNvPr>
@@ -2056,7 +2056,7 @@
                 <a:ea typeface="Arial"/>
                 <a:cs typeface="Arial"/>
               </a:rPr>
-              <a:t>Instrucciones dispersas en documentos de soporte</a:t>
+              <a:t>Las instrucciones están en varios documentos</a:t>
             </a:r>
           </a:p>
         </p:txBody>
@@ -2066,7 +2066,7 @@
           <p:cNvPr id="4" name="">
             <a:extLst xmlns:a="http://schemas.openxmlformats.org/drawingml/2006/main">
               <a:ext uri="{FF2B5EF4-FFF2-40B4-BE49-F238E27FC236}">
-                <a16:creationId xmlns:a16="http://schemas.microsoft.com/office/drawing/2014/main" id="{8E78675A-AEFA-40AA-949A-91FD2517BCB6}"/>
+                <a16:creationId xmlns:a16="http://schemas.microsoft.com/office/drawing/2014/main" id="{DB4FC16D-24F5-4CB3-8B87-606AB18B5059}"/>
               </a:ext>
             </a:extLst>
           </p:cNvPr>
@@ -2113,7 +2113,7 @@
                 <a:ea typeface="Arial"/>
                 <a:cs typeface="Arial"/>
               </a:rPr>
-              <a:t>El colaborador necesita encontrar el procedimiento aplicable y comprobar su origen.</a:t>
+              <a:t>La persona necesita saber qué hacer y dónde aparece esa información.</a:t>
             </a:r>
           </a:p>
         </p:txBody>
@@ -2123,7 +2123,7 @@
           <p:cNvPr id="5" name="">
             <a:extLst xmlns:a="http://schemas.openxmlformats.org/drawingml/2006/main">
               <a:ext uri="{FF2B5EF4-FFF2-40B4-BE49-F238E27FC236}">
-                <a16:creationId xmlns:a16="http://schemas.microsoft.com/office/drawing/2014/main" id="{C4DB43EE-F9C7-4E73-BD03-B311461852D0}"/>
+                <a16:creationId xmlns:a16="http://schemas.microsoft.com/office/drawing/2014/main" id="{FA7C3796-B60D-4F2A-A2A3-FF15EAF1A58E}"/>
               </a:ext>
             </a:extLst>
           </p:cNvPr>
@@ -2201,7 +2201,7 @@
     </p:spTree>
     <p:extLst>
       <p:ext uri="{BB962C8B-B14F-4D97-AF65-F5344CB8AC3E}">
-        <p14:creationId xmlns:p14="http://schemas.microsoft.com/office/powerpoint/2010/main" val="1349971365"/>
+        <p14:creationId xmlns:p14="http://schemas.microsoft.com/office/powerpoint/2010/main" val="1453344176"/>
       </p:ext>
     </p:extLst>
   </p:cSld>
@@ -2232,7 +2232,7 @@
           <p:cNvPr id="8" name="">
             <a:extLst xmlns:a="http://schemas.openxmlformats.org/drawingml/2006/main">
               <a:ext uri="{FF2B5EF4-FFF2-40B4-BE49-F238E27FC236}">
-                <a16:creationId xmlns:a16="http://schemas.microsoft.com/office/drawing/2014/main" id="{94257618-BD81-4FE9-A2C2-22ABFD747F74}"/>
+                <a16:creationId xmlns:a16="http://schemas.microsoft.com/office/drawing/2014/main" id="{64116169-F3C7-4E88-8306-65A38B0547A2}"/>
               </a:ext>
             </a:extLst>
           </p:cNvPr>
@@ -2279,7 +2279,7 @@
                 <a:ea typeface="Arial"/>
                 <a:cs typeface="Arial"/>
               </a:rPr>
-              <a:t>Conocimiento y objetivos</a:t>
+              <a:t>Documentos y objetivo</a:t>
             </a:r>
           </a:p>
         </p:txBody>
@@ -2289,7 +2289,7 @@
           <p:cNvPr id="2" name="">
             <a:extLst xmlns:a="http://schemas.openxmlformats.org/drawingml/2006/main">
               <a:ext uri="{FF2B5EF4-FFF2-40B4-BE49-F238E27FC236}">
-                <a16:creationId xmlns:a16="http://schemas.microsoft.com/office/drawing/2014/main" id="{116D3CC1-1B3A-476E-A093-DD40323C08E1}"/>
+                <a16:creationId xmlns:a16="http://schemas.microsoft.com/office/drawing/2014/main" id="{9A00720A-53EE-461E-922E-3C9B19964A0D}"/>
               </a:ext>
             </a:extLst>
           </p:cNvPr>
@@ -2346,7 +2346,7 @@
           <p:cNvPr id="3" name="">
             <a:extLst xmlns:a="http://schemas.openxmlformats.org/drawingml/2006/main">
               <a:ext uri="{FF2B5EF4-FFF2-40B4-BE49-F238E27FC236}">
-                <a16:creationId xmlns:a16="http://schemas.microsoft.com/office/drawing/2014/main" id="{E05033FD-1AEE-4CFA-B69D-E659FE8B0443}"/>
+                <a16:creationId xmlns:a16="http://schemas.microsoft.com/office/drawing/2014/main" id="{E59E24AF-975D-4FBB-BAAB-2D4EE8A60AF6}"/>
               </a:ext>
             </a:extLst>
           </p:cNvPr>
@@ -2403,7 +2403,7 @@
           <p:cNvPr id="4" name="">
             <a:extLst xmlns:a="http://schemas.openxmlformats.org/drawingml/2006/main">
               <a:ext uri="{FF2B5EF4-FFF2-40B4-BE49-F238E27FC236}">
-                <a16:creationId xmlns:a16="http://schemas.microsoft.com/office/drawing/2014/main" id="{7734B59C-B7EE-4220-B2E6-DB3B3134FE35}"/>
+                <a16:creationId xmlns:a16="http://schemas.microsoft.com/office/drawing/2014/main" id="{C3CB410B-4A03-49B8-B468-2FE47343ECB2}"/>
               </a:ext>
             </a:extLst>
           </p:cNvPr>
@@ -2460,7 +2460,7 @@
           <p:cNvPr id="5" name="">
             <a:extLst xmlns:a="http://schemas.openxmlformats.org/drawingml/2006/main">
               <a:ext uri="{FF2B5EF4-FFF2-40B4-BE49-F238E27FC236}">
-                <a16:creationId xmlns:a16="http://schemas.microsoft.com/office/drawing/2014/main" id="{F1AA3708-1FAA-46F4-B47F-BE975EC382F1}"/>
+                <a16:creationId xmlns:a16="http://schemas.microsoft.com/office/drawing/2014/main" id="{FC0F4AC7-103D-483B-B4AC-73BB73C2DFB0}"/>
               </a:ext>
             </a:extLst>
           </p:cNvPr>
@@ -2517,7 +2517,7 @@
           <p:cNvPr id="6" name="">
             <a:extLst xmlns:a="http://schemas.openxmlformats.org/drawingml/2006/main">
               <a:ext uri="{FF2B5EF4-FFF2-40B4-BE49-F238E27FC236}">
-                <a16:creationId xmlns:a16="http://schemas.microsoft.com/office/drawing/2014/main" id="{619453E6-391C-4BD9-A67A-BEE1EEA22EA1}"/>
+                <a16:creationId xmlns:a16="http://schemas.microsoft.com/office/drawing/2014/main" id="{90297135-AC82-44FA-8E0D-DA4459524AB3}"/>
               </a:ext>
             </a:extLst>
           </p:cNvPr>
@@ -2574,7 +2574,7 @@
           <p:cNvPr id="7" name="">
             <a:extLst xmlns:a="http://schemas.openxmlformats.org/drawingml/2006/main">
               <a:ext uri="{FF2B5EF4-FFF2-40B4-BE49-F238E27FC236}">
-                <a16:creationId xmlns:a16="http://schemas.microsoft.com/office/drawing/2014/main" id="{7D89BB06-E17B-4B54-B3AB-8B65F1629C80}"/>
+                <a16:creationId xmlns:a16="http://schemas.microsoft.com/office/drawing/2014/main" id="{1273A3D0-592D-4DFD-B6B7-6CF30BF6BF9A}"/>
               </a:ext>
             </a:extLst>
           </p:cNvPr>
@@ -2629,7 +2629,7 @@
     </p:spTree>
     <p:extLst>
       <p:ext uri="{BB962C8B-B14F-4D97-AF65-F5344CB8AC3E}">
-        <p14:creationId xmlns:p14="http://schemas.microsoft.com/office/powerpoint/2010/main" val="1272685567"/>
+        <p14:creationId xmlns:p14="http://schemas.microsoft.com/office/powerpoint/2010/main" val="35971989"/>
       </p:ext>
     </p:extLst>
   </p:cSld>
@@ -2660,7 +2660,7 @@
           <p:cNvPr id="19" name="">
             <a:extLst xmlns:a="http://schemas.openxmlformats.org/drawingml/2006/main">
               <a:ext uri="{FF2B5EF4-FFF2-40B4-BE49-F238E27FC236}">
-                <a16:creationId xmlns:a16="http://schemas.microsoft.com/office/drawing/2014/main" id="{EE3C8F8D-12F6-4384-BCD8-ABBD1FB0A08F}"/>
+                <a16:creationId xmlns:a16="http://schemas.microsoft.com/office/drawing/2014/main" id="{815B7CA4-96F3-4394-8613-A7342489687B}"/>
               </a:ext>
             </a:extLst>
           </p:cNvPr>
@@ -2707,7 +2707,7 @@
                 <a:ea typeface="Arial"/>
                 <a:cs typeface="Arial"/>
               </a:rPr>
-              <a:t>Arquitectura de la solución</a:t>
+              <a:t>Cómo funciona Nexo</a:t>
             </a:r>
           </a:p>
         </p:txBody>
@@ -2717,7 +2717,7 @@
           <p:cNvPr id="2" name="">
             <a:extLst xmlns:a="http://schemas.openxmlformats.org/drawingml/2006/main">
               <a:ext uri="{FF2B5EF4-FFF2-40B4-BE49-F238E27FC236}">
-                <a16:creationId xmlns:a16="http://schemas.microsoft.com/office/drawing/2014/main" id="{2DABDB04-6922-46FC-9CC4-11137F896A02}"/>
+                <a16:creationId xmlns:a16="http://schemas.microsoft.com/office/drawing/2014/main" id="{F6D07B18-16CF-48FB-97F9-CA1BF25F84E1}"/>
               </a:ext>
             </a:extLst>
           </p:cNvPr>
@@ -2774,7 +2774,7 @@
           <p:cNvPr id="3" name="">
             <a:extLst xmlns:a="http://schemas.openxmlformats.org/drawingml/2006/main">
               <a:ext uri="{FF2B5EF4-FFF2-40B4-BE49-F238E27FC236}">
-                <a16:creationId xmlns:a16="http://schemas.microsoft.com/office/drawing/2014/main" id="{474725F5-B40A-44F1-B242-2819021DB404}"/>
+                <a16:creationId xmlns:a16="http://schemas.microsoft.com/office/drawing/2014/main" id="{302B6753-DFB4-41EC-AB4F-834455D9BA5B}"/>
               </a:ext>
             </a:extLst>
           </p:cNvPr>
@@ -2835,7 +2835,7 @@
           <p:cNvPr id="4" name="">
             <a:extLst xmlns:a="http://schemas.openxmlformats.org/drawingml/2006/main">
               <a:ext uri="{FF2B5EF4-FFF2-40B4-BE49-F238E27FC236}">
-                <a16:creationId xmlns:a16="http://schemas.microsoft.com/office/drawing/2014/main" id="{101B8F18-D560-4DB8-9E78-4502BF97ECE1}"/>
+                <a16:creationId xmlns:a16="http://schemas.microsoft.com/office/drawing/2014/main" id="{54B858A6-D99B-4281-9520-F8CDDC8079F7}"/>
               </a:ext>
             </a:extLst>
           </p:cNvPr>
@@ -2896,7 +2896,7 @@
           <p:cNvPr id="5" name="">
             <a:extLst xmlns:a="http://schemas.openxmlformats.org/drawingml/2006/main">
               <a:ext uri="{FF2B5EF4-FFF2-40B4-BE49-F238E27FC236}">
-                <a16:creationId xmlns:a16="http://schemas.microsoft.com/office/drawing/2014/main" id="{E4151539-83D6-4F46-9F5A-319734096E88}"/>
+                <a16:creationId xmlns:a16="http://schemas.microsoft.com/office/drawing/2014/main" id="{C67B31B5-1AC1-41CD-8138-D240B775AFDC}"/>
               </a:ext>
             </a:extLst>
           </p:cNvPr>
@@ -2957,7 +2957,7 @@
           <p:cNvPr id="6" name="">
             <a:extLst xmlns:a="http://schemas.openxmlformats.org/drawingml/2006/main">
               <a:ext uri="{FF2B5EF4-FFF2-40B4-BE49-F238E27FC236}">
-                <a16:creationId xmlns:a16="http://schemas.microsoft.com/office/drawing/2014/main" id="{EBDA80CC-E02A-4338-8A52-B40B75D84FA7}"/>
+                <a16:creationId xmlns:a16="http://schemas.microsoft.com/office/drawing/2014/main" id="{3B919FBB-BA76-4B04-9F4E-CF364F056BC0}"/>
               </a:ext>
             </a:extLst>
           </p:cNvPr>
@@ -3018,7 +3018,7 @@
           <p:cNvPr id="7" name="">
             <a:extLst xmlns:a="http://schemas.openxmlformats.org/drawingml/2006/main">
               <a:ext uri="{FF2B5EF4-FFF2-40B4-BE49-F238E27FC236}">
-                <a16:creationId xmlns:a16="http://schemas.microsoft.com/office/drawing/2014/main" id="{4D045AC9-D2A5-4B9C-96E9-5A8C035B006B}"/>
+                <a16:creationId xmlns:a16="http://schemas.microsoft.com/office/drawing/2014/main" id="{5CAB3437-7A5F-4D27-9EB1-E48FE74194B7}"/>
               </a:ext>
             </a:extLst>
           </p:cNvPr>
@@ -3079,7 +3079,7 @@
           <p:cNvPr id="8" name="">
             <a:extLst xmlns:a="http://schemas.openxmlformats.org/drawingml/2006/main">
               <a:ext uri="{FF2B5EF4-FFF2-40B4-BE49-F238E27FC236}">
-                <a16:creationId xmlns:a16="http://schemas.microsoft.com/office/drawing/2014/main" id="{74D804B7-0C25-4388-B48C-17E4A5D749BC}"/>
+                <a16:creationId xmlns:a16="http://schemas.microsoft.com/office/drawing/2014/main" id="{78AAAB09-DD3F-4EBF-AC93-0D53E453ED67}"/>
               </a:ext>
             </a:extLst>
           </p:cNvPr>
@@ -3140,7 +3140,7 @@
           <p:cNvPr id="9" name="">
             <a:extLst xmlns:a="http://schemas.openxmlformats.org/drawingml/2006/main">
               <a:ext uri="{FF2B5EF4-FFF2-40B4-BE49-F238E27FC236}">
-                <a16:creationId xmlns:a16="http://schemas.microsoft.com/office/drawing/2014/main" id="{CD78ACDB-A2A8-4D30-A4CD-EBA21CD69B5A}"/>
+                <a16:creationId xmlns:a16="http://schemas.microsoft.com/office/drawing/2014/main" id="{DA3103A6-0DA5-4A9B-B7B3-6A36938EAC0F}"/>
               </a:ext>
             </a:extLst>
           </p:cNvPr>
@@ -3201,7 +3201,7 @@
           <p:cNvPr id="10" name="">
             <a:extLst xmlns:a="http://schemas.openxmlformats.org/drawingml/2006/main">
               <a:ext uri="{FF2B5EF4-FFF2-40B4-BE49-F238E27FC236}">
-                <a16:creationId xmlns:a16="http://schemas.microsoft.com/office/drawing/2014/main" id="{151FD614-6714-4C49-95BF-852D81DD29C7}"/>
+                <a16:creationId xmlns:a16="http://schemas.microsoft.com/office/drawing/2014/main" id="{9645EA09-141A-4F5F-A8E5-EE5BF779F020}"/>
               </a:ext>
             </a:extLst>
           </p:cNvPr>
@@ -3437,7 +3437,7 @@
           <p:cNvPr id="18" name="">
             <a:extLst xmlns:a="http://schemas.openxmlformats.org/drawingml/2006/main">
               <a:ext uri="{FF2B5EF4-FFF2-40B4-BE49-F238E27FC236}">
-                <a16:creationId xmlns:a16="http://schemas.microsoft.com/office/drawing/2014/main" id="{B5A86D6F-EE67-433D-8FA5-4A19DFE0CF60}"/>
+                <a16:creationId xmlns:a16="http://schemas.microsoft.com/office/drawing/2014/main" id="{C2DC1504-EFBC-463D-9D50-5C6243BC2A5D}"/>
               </a:ext>
             </a:extLst>
           </p:cNvPr>
@@ -3492,7 +3492,7 @@
     </p:spTree>
     <p:extLst>
       <p:ext uri="{BB962C8B-B14F-4D97-AF65-F5344CB8AC3E}">
-        <p14:creationId xmlns:p14="http://schemas.microsoft.com/office/powerpoint/2010/main" val="1887111638"/>
+        <p14:creationId xmlns:p14="http://schemas.microsoft.com/office/powerpoint/2010/main" val="1384366859"/>
       </p:ext>
     </p:extLst>
   </p:cSld>
@@ -3523,7 +3523,7 @@
           <p:cNvPr id="5" name="">
             <a:extLst xmlns:a="http://schemas.openxmlformats.org/drawingml/2006/main">
               <a:ext uri="{FF2B5EF4-FFF2-40B4-BE49-F238E27FC236}">
-                <a16:creationId xmlns:a16="http://schemas.microsoft.com/office/drawing/2014/main" id="{2ACC1288-3EA2-44AD-B7D4-EB7B6B5659A0}"/>
+                <a16:creationId xmlns:a16="http://schemas.microsoft.com/office/drawing/2014/main" id="{8578D963-1522-4C7C-B71E-D64703FCC01A}"/>
               </a:ext>
             </a:extLst>
           </p:cNvPr>
@@ -3580,7 +3580,7 @@
           <p:cNvPr id="2" name="">
             <a:extLst xmlns:a="http://schemas.openxmlformats.org/drawingml/2006/main">
               <a:ext uri="{FF2B5EF4-FFF2-40B4-BE49-F238E27FC236}">
-                <a16:creationId xmlns:a16="http://schemas.microsoft.com/office/drawing/2014/main" id="{59327A68-9B8F-473C-9B46-53DE66492F90}"/>
+                <a16:creationId xmlns:a16="http://schemas.microsoft.com/office/drawing/2014/main" id="{E25107BC-7AA1-4538-9096-6CD1BC546481}"/>
               </a:ext>
             </a:extLst>
           </p:cNvPr>
@@ -3637,7 +3637,7 @@
           <p:cNvPr id="3" name="">
             <a:extLst xmlns:a="http://schemas.openxmlformats.org/drawingml/2006/main">
               <a:ext uri="{FF2B5EF4-FFF2-40B4-BE49-F238E27FC236}">
-                <a16:creationId xmlns:a16="http://schemas.microsoft.com/office/drawing/2014/main" id="{B24EAA44-5257-446B-B03B-2C7EB0DDFE6E}"/>
+                <a16:creationId xmlns:a16="http://schemas.microsoft.com/office/drawing/2014/main" id="{B420832C-EC1A-4329-B334-CFAC3F7352D7}"/>
               </a:ext>
             </a:extLst>
           </p:cNvPr>
@@ -3717,7 +3717,7 @@
           <p:cNvPr id="4" name="">
             <a:extLst xmlns:a="http://schemas.openxmlformats.org/drawingml/2006/main">
               <a:ext uri="{FF2B5EF4-FFF2-40B4-BE49-F238E27FC236}">
-                <a16:creationId xmlns:a16="http://schemas.microsoft.com/office/drawing/2014/main" id="{A0857D5F-B302-4464-B0F5-68541C26872B}"/>
+                <a16:creationId xmlns:a16="http://schemas.microsoft.com/office/drawing/2014/main" id="{E3A38A60-9EB1-4FD9-96D2-B474513F29B6}"/>
               </a:ext>
             </a:extLst>
           </p:cNvPr>
@@ -3841,7 +3841,7 @@
     </p:spTree>
     <p:extLst>
       <p:ext uri="{BB962C8B-B14F-4D97-AF65-F5344CB8AC3E}">
-        <p14:creationId xmlns:p14="http://schemas.microsoft.com/office/powerpoint/2010/main" val="2104045196"/>
+        <p14:creationId xmlns:p14="http://schemas.microsoft.com/office/powerpoint/2010/main" val="1685976936"/>
       </p:ext>
     </p:extLst>
   </p:cSld>
@@ -3872,7 +3872,7 @@
           <p:cNvPr id="6" name="">
             <a:extLst xmlns:a="http://schemas.openxmlformats.org/drawingml/2006/main">
               <a:ext uri="{FF2B5EF4-FFF2-40B4-BE49-F238E27FC236}">
-                <a16:creationId xmlns:a16="http://schemas.microsoft.com/office/drawing/2014/main" id="{09111932-315B-46E8-A7E2-4631B57DAF81}"/>
+                <a16:creationId xmlns:a16="http://schemas.microsoft.com/office/drawing/2014/main" id="{F45D27B6-0EC1-40BD-98F0-FC30A920EB9D}"/>
               </a:ext>
             </a:extLst>
           </p:cNvPr>
@@ -3919,7 +3919,7 @@
                 <a:ea typeface="Arial"/>
                 <a:cs typeface="Arial"/>
               </a:rPr>
-              <a:t>Demostración y trazabilidad</a:t>
+              <a:t>Una consulta paso a paso</a:t>
             </a:r>
           </a:p>
         </p:txBody>
@@ -3929,7 +3929,7 @@
           <p:cNvPr id="2" name="">
             <a:extLst xmlns:a="http://schemas.openxmlformats.org/drawingml/2006/main">
               <a:ext uri="{FF2B5EF4-FFF2-40B4-BE49-F238E27FC236}">
-                <a16:creationId xmlns:a16="http://schemas.microsoft.com/office/drawing/2014/main" id="{D4CBB74B-81DF-4FC1-88C6-5D19B9E7289D}"/>
+                <a16:creationId xmlns:a16="http://schemas.microsoft.com/office/drawing/2014/main" id="{E8799987-DE0B-45C2-A2DD-EBB5C938A006}"/>
               </a:ext>
             </a:extLst>
           </p:cNvPr>
@@ -3986,7 +3986,7 @@
           <p:cNvPr id="3" name="">
             <a:extLst xmlns:a="http://schemas.openxmlformats.org/drawingml/2006/main">
               <a:ext uri="{FF2B5EF4-FFF2-40B4-BE49-F238E27FC236}">
-                <a16:creationId xmlns:a16="http://schemas.microsoft.com/office/drawing/2014/main" id="{CCE9578E-9241-477F-A467-BD579B9D8EC4}"/>
+                <a16:creationId xmlns:a16="http://schemas.microsoft.com/office/drawing/2014/main" id="{A8C671B6-DBB7-4A53-ADF1-7D8C29015CF7}"/>
               </a:ext>
             </a:extLst>
           </p:cNvPr>
@@ -4043,7 +4043,7 @@
           <p:cNvPr id="4" name="">
             <a:extLst xmlns:a="http://schemas.openxmlformats.org/drawingml/2006/main">
               <a:ext uri="{FF2B5EF4-FFF2-40B4-BE49-F238E27FC236}">
-                <a16:creationId xmlns:a16="http://schemas.microsoft.com/office/drawing/2014/main" id="{C03D013B-B3A4-49DF-96D5-C93B5F4B7884}"/>
+                <a16:creationId xmlns:a16="http://schemas.microsoft.com/office/drawing/2014/main" id="{B207694E-597C-45BD-BBBD-DB9286F98212}"/>
               </a:ext>
             </a:extLst>
           </p:cNvPr>
@@ -4146,7 +4146,7 @@
           <p:cNvPr id="5" name="">
             <a:extLst xmlns:a="http://schemas.openxmlformats.org/drawingml/2006/main">
               <a:ext uri="{FF2B5EF4-FFF2-40B4-BE49-F238E27FC236}">
-                <a16:creationId xmlns:a16="http://schemas.microsoft.com/office/drawing/2014/main" id="{75505487-27E8-4679-8E2B-7CA04C9C8BE0}"/>
+                <a16:creationId xmlns:a16="http://schemas.microsoft.com/office/drawing/2014/main" id="{E06F89A6-FD8D-419E-ADF9-A5DEA1FF0CEA}"/>
               </a:ext>
             </a:extLst>
           </p:cNvPr>
@@ -4201,7 +4201,7 @@
     </p:spTree>
     <p:extLst>
       <p:ext uri="{BB962C8B-B14F-4D97-AF65-F5344CB8AC3E}">
-        <p14:creationId xmlns:p14="http://schemas.microsoft.com/office/powerpoint/2010/main" val="491635744"/>
+        <p14:creationId xmlns:p14="http://schemas.microsoft.com/office/powerpoint/2010/main" val="1496007134"/>
       </p:ext>
     </p:extLst>
   </p:cSld>
@@ -4232,7 +4232,7 @@
           <p:cNvPr id="9" name="">
             <a:extLst xmlns:a="http://schemas.openxmlformats.org/drawingml/2006/main">
               <a:ext uri="{FF2B5EF4-FFF2-40B4-BE49-F238E27FC236}">
-                <a16:creationId xmlns:a16="http://schemas.microsoft.com/office/drawing/2014/main" id="{79AF92EB-0CA4-4ECC-B35F-90B292EF9ED7}"/>
+                <a16:creationId xmlns:a16="http://schemas.microsoft.com/office/drawing/2014/main" id="{F5A8F478-6F06-4554-9D64-311AF7DE9F54}"/>
               </a:ext>
             </a:extLst>
           </p:cNvPr>
@@ -4279,7 +4279,7 @@
                 <a:ea typeface="Arial"/>
                 <a:cs typeface="Arial"/>
               </a:rPr>
-              <a:t>Resultados de recuperación</a:t>
+              <a:t>Resultados de las pruebas</a:t>
             </a:r>
           </a:p>
         </p:txBody>
@@ -4289,7 +4289,7 @@
           <p:cNvPr id="2" name="">
             <a:extLst xmlns:a="http://schemas.openxmlformats.org/drawingml/2006/main">
               <a:ext uri="{FF2B5EF4-FFF2-40B4-BE49-F238E27FC236}">
-                <a16:creationId xmlns:a16="http://schemas.microsoft.com/office/drawing/2014/main" id="{B50B5275-785A-4683-B80E-54AB1FBB0E54}"/>
+                <a16:creationId xmlns:a16="http://schemas.microsoft.com/office/drawing/2014/main" id="{C4F8B3F9-8B76-4421-9A9A-3A40A37CA7EE}"/>
               </a:ext>
             </a:extLst>
           </p:cNvPr>
@@ -4346,7 +4346,7 @@
           <p:cNvPr id="3" name="">
             <a:extLst xmlns:a="http://schemas.openxmlformats.org/drawingml/2006/main">
               <a:ext uri="{FF2B5EF4-FFF2-40B4-BE49-F238E27FC236}">
-                <a16:creationId xmlns:a16="http://schemas.microsoft.com/office/drawing/2014/main" id="{996C4DDF-4045-4238-81BE-0DF240774874}"/>
+                <a16:creationId xmlns:a16="http://schemas.microsoft.com/office/drawing/2014/main" id="{B72C7189-0D83-4FF5-AFF0-EA8C144FC97E}"/>
               </a:ext>
             </a:extLst>
           </p:cNvPr>
@@ -4403,7 +4403,7 @@
           <p:cNvPr id="4" name="">
             <a:extLst xmlns:a="http://schemas.openxmlformats.org/drawingml/2006/main">
               <a:ext uri="{FF2B5EF4-FFF2-40B4-BE49-F238E27FC236}">
-                <a16:creationId xmlns:a16="http://schemas.microsoft.com/office/drawing/2014/main" id="{F86BC7D7-D7A5-4608-91EC-A66F8E7838A7}"/>
+                <a16:creationId xmlns:a16="http://schemas.microsoft.com/office/drawing/2014/main" id="{9F9BAAD1-D0B3-43D7-9C40-A0F82712CE4D}"/>
               </a:ext>
             </a:extLst>
           </p:cNvPr>
@@ -4460,7 +4460,7 @@
           <p:cNvPr id="5" name="">
             <a:extLst xmlns:a="http://schemas.openxmlformats.org/drawingml/2006/main">
               <a:ext uri="{FF2B5EF4-FFF2-40B4-BE49-F238E27FC236}">
-                <a16:creationId xmlns:a16="http://schemas.microsoft.com/office/drawing/2014/main" id="{7283C44C-1FE9-474C-8DF1-5F666E30BCA8}"/>
+                <a16:creationId xmlns:a16="http://schemas.microsoft.com/office/drawing/2014/main" id="{99A43A8D-F727-4C36-9668-4D9FEB38757B}"/>
               </a:ext>
             </a:extLst>
           </p:cNvPr>
@@ -4517,7 +4517,7 @@
           <p:cNvPr id="6" name="">
             <a:extLst xmlns:a="http://schemas.openxmlformats.org/drawingml/2006/main">
               <a:ext uri="{FF2B5EF4-FFF2-40B4-BE49-F238E27FC236}">
-                <a16:creationId xmlns:a16="http://schemas.microsoft.com/office/drawing/2014/main" id="{680D48C2-39CE-43D5-89D1-670B48AC618B}"/>
+                <a16:creationId xmlns:a16="http://schemas.microsoft.com/office/drawing/2014/main" id="{7604F1AB-A6BD-47AE-ACD0-AB43C98DB710}"/>
               </a:ext>
             </a:extLst>
           </p:cNvPr>
@@ -4574,7 +4574,7 @@
           <p:cNvPr id="7" name="">
             <a:extLst xmlns:a="http://schemas.openxmlformats.org/drawingml/2006/main">
               <a:ext uri="{FF2B5EF4-FFF2-40B4-BE49-F238E27FC236}">
-                <a16:creationId xmlns:a16="http://schemas.microsoft.com/office/drawing/2014/main" id="{FA1142A4-E68F-4963-AE91-DD659FE9779C}"/>
+                <a16:creationId xmlns:a16="http://schemas.microsoft.com/office/drawing/2014/main" id="{D42BEB33-5D4D-46F1-8372-2D6E00EAE300}"/>
               </a:ext>
             </a:extLst>
           </p:cNvPr>
@@ -4621,7 +4621,7 @@
                 <a:ea typeface="Arial"/>
                 <a:cs typeface="Arial"/>
               </a:rPr>
-              <a:t>12 consultas evaluadas. Abstención correcta en 2 de 2 casos sin evidencia.</a:t>
+              <a:t>10 respuestas con citas y 2 consultas sin información.</a:t>
             </a:r>
           </a:p>
           <a:p xmlns:a="http://schemas.openxmlformats.org/drawingml/2006/main">
@@ -4644,7 +4644,7 @@
                 <a:ea typeface="Arial"/>
                 <a:cs typeface="Arial"/>
               </a:rPr>
-              <a:t>9 controles de software aprobados.</a:t>
+              <a:t>Tiempo mediano de respuesta con el modelo: 3,7 segundos.</a:t>
             </a:r>
           </a:p>
         </p:txBody>
@@ -4654,7 +4654,7 @@
           <p:cNvPr id="8" name="">
             <a:extLst xmlns:a="http://schemas.openxmlformats.org/drawingml/2006/main">
               <a:ext uri="{FF2B5EF4-FFF2-40B4-BE49-F238E27FC236}">
-                <a16:creationId xmlns:a16="http://schemas.microsoft.com/office/drawing/2014/main" id="{40E105A3-FAFE-4657-9BDD-F592FBC9B3F3}"/>
+                <a16:creationId xmlns:a16="http://schemas.microsoft.com/office/drawing/2014/main" id="{47B6E277-CA36-4703-9F99-08AB03549F0C}"/>
               </a:ext>
             </a:extLst>
           </p:cNvPr>
@@ -4701,7 +4701,7 @@
                 <a:ea typeface="Arial"/>
                 <a:cs typeface="Arial"/>
               </a:rPr>
-              <a:t>Resultados del modo documental. La fidelidad del LLM sigue pendiente.</a:t>
+              <a:t>También se probaron 4 consultas de seguimiento y límites del asistente.</a:t>
             </a:r>
           </a:p>
         </p:txBody>
@@ -4709,7 +4709,7 @@
     </p:spTree>
     <p:extLst>
       <p:ext uri="{BB962C8B-B14F-4D97-AF65-F5344CB8AC3E}">
-        <p14:creationId xmlns:p14="http://schemas.microsoft.com/office/powerpoint/2010/main" val="1056788669"/>
+        <p14:creationId xmlns:p14="http://schemas.microsoft.com/office/powerpoint/2010/main" val="1893692314"/>
       </p:ext>
     </p:extLst>
   </p:cSld>
@@ -4740,7 +4740,7 @@
           <p:cNvPr id="5" name="">
             <a:extLst xmlns:a="http://schemas.openxmlformats.org/drawingml/2006/main">
               <a:ext uri="{FF2B5EF4-FFF2-40B4-BE49-F238E27FC236}">
-                <a16:creationId xmlns:a16="http://schemas.microsoft.com/office/drawing/2014/main" id="{25A77307-967E-4F65-B980-B1560F7DA9AD}"/>
+                <a16:creationId xmlns:a16="http://schemas.microsoft.com/office/drawing/2014/main" id="{1CA115ED-5FEA-45C3-81C8-84E0C13D5FA7}"/>
               </a:ext>
             </a:extLst>
           </p:cNvPr>
@@ -4787,7 +4787,7 @@
                 <a:ea typeface="Arial"/>
                 <a:cs typeface="Arial"/>
               </a:rPr>
-              <a:t>Límites y siguiente validación</a:t>
+              <a:t>Qué falta mejorar</a:t>
             </a:r>
           </a:p>
         </p:txBody>
@@ -4797,7 +4797,7 @@
           <p:cNvPr id="2" name="">
             <a:extLst xmlns:a="http://schemas.openxmlformats.org/drawingml/2006/main">
               <a:ext uri="{FF2B5EF4-FFF2-40B4-BE49-F238E27FC236}">
-                <a16:creationId xmlns:a16="http://schemas.microsoft.com/office/drawing/2014/main" id="{F02206F2-AB4D-4694-9E67-B5C294A2A53F}"/>
+                <a16:creationId xmlns:a16="http://schemas.microsoft.com/office/drawing/2014/main" id="{8C9E3F60-5BB7-4ADD-B95B-4DE12B01CC12}"/>
               </a:ext>
             </a:extLst>
           </p:cNvPr>
@@ -4854,7 +4854,7 @@
           <p:cNvPr id="3" name="">
             <a:extLst xmlns:a="http://schemas.openxmlformats.org/drawingml/2006/main">
               <a:ext uri="{FF2B5EF4-FFF2-40B4-BE49-F238E27FC236}">
-                <a16:creationId xmlns:a16="http://schemas.microsoft.com/office/drawing/2014/main" id="{6975EF9E-4241-4D20-B3FF-B58F1061F671}"/>
+                <a16:creationId xmlns:a16="http://schemas.microsoft.com/office/drawing/2014/main" id="{0E434C0E-0A86-4F60-85D5-833A1F77B178}"/>
               </a:ext>
             </a:extLst>
           </p:cNvPr>
@@ -4901,7 +4901,7 @@
                 <a:ea typeface="Arial"/>
                 <a:cs typeface="Arial"/>
               </a:rPr>
-              <a:t>La recuperación está medida.</a:t>
+              <a:t>El asistente funciona, pero una cita válida</a:t>
             </a:r>
           </a:p>
           <a:p xmlns:a="http://schemas.openxmlformats.org/drawingml/2006/main">
@@ -4924,7 +4924,7 @@
                 <a:ea typeface="Arial"/>
                 <a:cs typeface="Arial"/>
               </a:rPr>
-              <a:t>La generación y el beneficio operativo requieren evaluación.</a:t>
+              <a:t>no asegura que cada frase sea precisa.</a:t>
             </a:r>
           </a:p>
         </p:txBody>
@@ -4934,7 +4934,7 @@
           <p:cNvPr id="4" name="">
             <a:extLst xmlns:a="http://schemas.openxmlformats.org/drawingml/2006/main">
               <a:ext uri="{FF2B5EF4-FFF2-40B4-BE49-F238E27FC236}">
-                <a16:creationId xmlns:a16="http://schemas.microsoft.com/office/drawing/2014/main" id="{77BD24B2-A677-4F25-9260-CEF5BFA35E16}"/>
+                <a16:creationId xmlns:a16="http://schemas.microsoft.com/office/drawing/2014/main" id="{A55CBE6A-BEA3-470B-8C14-681F11C6DF17}"/>
               </a:ext>
             </a:extLst>
           </p:cNvPr>
@@ -4981,7 +4981,7 @@
                 <a:ea typeface="Arial"/>
                 <a:cs typeface="Arial"/>
               </a:rPr>
-              <a:t>Ejecutar el LLM y revisar cada afirmación contra sus fuentes.</a:t>
+              <a:t>Revisar cómo explica plazos y recomendaciones de seguridad.</a:t>
             </a:r>
           </a:p>
           <a:p xmlns:a="http://schemas.openxmlformats.org/drawingml/2006/main">
@@ -5004,7 +5004,7 @@
                 <a:ea typeface="Arial"/>
                 <a:cs typeface="Arial"/>
               </a:rPr>
-              <a:t>Ampliar consultas independientes y casos adversarios.</a:t>
+              <a:t>Probar más preguntas, documentos y usuarios.</a:t>
             </a:r>
           </a:p>
           <a:p xmlns:a="http://schemas.openxmlformats.org/drawingml/2006/main">
@@ -5027,7 +5027,7 @@
                 <a:ea typeface="Arial"/>
                 <a:cs typeface="Arial"/>
               </a:rPr>
-              <a:t>Comparar tiempo de búsqueda manual y asistida.</a:t>
+              <a:t>Comparar el tiempo de búsqueda con y sin Nexo.</a:t>
             </a:r>
           </a:p>
           <a:p xmlns:a="http://schemas.openxmlformats.org/drawingml/2006/main">
@@ -5050,7 +5050,7 @@
                 <a:ea typeface="Arial"/>
                 <a:cs typeface="Arial"/>
               </a:rPr>
-              <a:t>Añadir permisos por documento antes de uso institucional.</a:t>
+              <a:t>Agregar permisos antes de usar datos de una empresa.</a:t>
             </a:r>
           </a:p>
         </p:txBody>
@@ -5058,7 +5058,7 @@
     </p:spTree>
     <p:extLst>
       <p:ext uri="{BB962C8B-B14F-4D97-AF65-F5344CB8AC3E}">
-        <p14:creationId xmlns:p14="http://schemas.microsoft.com/office/powerpoint/2010/main" val="662925832"/>
+        <p14:creationId xmlns:p14="http://schemas.microsoft.com/office/powerpoint/2010/main" val="884118842"/>
       </p:ext>
     </p:extLst>
   </p:cSld>

</xml_diff>